<commit_message>
docs: 2강 ZCode connects via shared Z.ai account login (slides 16/20/21/23/26-28, notes, scripts)
Co-Authored-By: Claude Fable 5 <noreply@anthropic.com>
</commit_message>
<xml_diff>
--- a/data/생성형 AI 소프트웨어공학/생성형AI소프트웨어공학_2강.pptx
+++ b/data/생성형 AI 소프트웨어공학/생성형AI소프트웨어공학_2강.pptx
@@ -545,7 +545,7 @@
           <a:p>
             <a:r>
               <a:rPr lang="ko-KR"/>
-              <a:t>뒷부분은 실습입니다. AI 에이전트 두 개를 붙입니다. 하나는 Codex, VS Code 안에 들어오는 OpenAI의 에이전트인데 ChatGPT 무료 계정으로 로그인만 하면 됩니다. 또 하나는 ZCode, 따로 설치하는 프로그램인데 제가 나눠 드리는 수업 공용 키로 연결합니다. 그리고 첫 지시까지 내려 봅니다. 수업 끝날 때쯤이면 여러분이 한국어로 "이런 파일 만들어 줘"라고 치면 AI가 실제로 파일을 만들어 주는 걸 보게 됩니다.</a:t>
+              <a:t>뒷부분은 실습입니다. AI 에이전트 두 개를 붙입니다. 하나는 Codex, VS Code 안에 들어오는 OpenAI의 에이전트인데 ChatGPT 무료 계정으로 로그인만 하면 됩니다. 또 하나는 ZCode, 따로 설치하는 프로그램인데 제가 수업 공용 계정으로 로그인해 드립니다. 그리고 첫 지시까지 내려 봅니다. 수업 끝날 때쯤이면 여러분이 한국어로 "이런 파일 만들어 줘"라고 치면 AI가 실제로 파일을 만들어 주는 걸 보게 됩니다.</a:t>
             </a:r>
           </a:p>
           <a:p/>
@@ -653,7 +653,7 @@
           <a:p>
             <a:r>
               <a:rPr lang="ko-KR"/>
-              <a:t>이번 주 성취 기준은 세 가지입니다. 첫째, 폭포수, 반복, 애자일 모델의 특징과 장단점을 비교해서 설명할 수 있다. 둘째, 어떤 프로젝트 상황이 주어졌을 때 맞는 방식을 고르고 그 이유를 말할 수 있다. 이게 시험에 나오는 형태입니다. 셋째, ChatGPT 계정으로 Codex에 로그인하고, 수업 공용 키로 ZCode를 연결해서 AI 에이전트의 동작을 확인할 수 있다. 오늘도 마지막 항목은 전원 완료가 목표입니다.</a:t>
+              <a:t>이번 주 성취 기준은 세 가지입니다. 첫째, 폭포수, 반복, 애자일 모델의 특징과 장단점을 비교해서 설명할 수 있다. 둘째, 어떤 프로젝트 상황이 주어졌을 때 맞는 방식을 고르고 그 이유를 말할 수 있다. 이게 시험에 나오는 형태입니다. 셋째, ChatGPT 계정으로 Codex에 로그인하고, 수업 공용 계정으로 ZCode를 연결해서 AI 에이전트의 동작을 확인할 수 있다. 오늘도 마지막 항목은 전원 완료가 목표입니다.</a:t>
             </a:r>
           </a:p>
           <a:p/>
@@ -2029,7 +2029,7 @@
           <a:p>
             <a:r>
               <a:rPr lang="ko-KR"/>
-              <a:t>순서는 여섯 단계입니다. ChatGPT 계정, Codex 확장 설치, Codex 로그인, ZCode 설치, ZCode에 공용 키 연결, 그리고 첫 지시. 지난주처럼 단계마다 슬라이드에 실제 화면과 확인 지점을 넣어 뒀습니다. 로그인해야만 보이는 화면 하나, Codex의 로그인 화면만 캡처 대신 '화면 구성도'로 그려 뒀고, ZCode 화면은 공식 문서의 실제 화면을 가져왔습니다. 여러분 실제 화면과 버튼 이름은 같으니 그대로 따라 하면 됩니다.</a:t>
+              <a:t>순서는 여섯 단계입니다. ChatGPT 계정, Codex 확장 설치, Codex 로그인, ZCode 설치, ZCode에 공용 계정 연결, 그리고 첫 지시. 지난주처럼 단계마다 슬라이드에 실제 화면과 확인 지점을 넣어 뒀습니다. 로그인해야만 보이는 화면 하나, Codex의 로그인 화면만 캡처 대신 '화면 구성도'로 그려 뒀고, ZCode 화면은 공식 문서의 실제 화면을 가져왔습니다. 여러분 실제 화면과 버튼 이름은 같으니 그대로 따라 하면 됩니다.</a:t>
             </a:r>
           </a:p>
           <a:p/>
@@ -2123,7 +2123,7 @@
           <a:p>
             <a:r>
               <a:rPr lang="ko-KR"/>
-              <a:t>방금 키를 넣었죠. 오늘 실습에서 제일 중요한 슬라이드입니다. API 키는 비밀번호입니다. 비밀번호를 포스트잇에 써서 모니터에 붙이지 않듯이, 키도 다루는 규칙이 있습니다. 수업 공용 키도, 여러분 ChatGPT 계정 비밀번호도 같은 규칙입니다.</a:t>
+              <a:t>두 도구가 붙었으니, 오늘 실습에서 제일 중요한 슬라이드를 하나 보고 갑니다. 키와 계정은 비밀번호입니다. 여러분이 오늘 직접 키를 만진 건 없지만, 앞으로 개발하면서 API 키를 다룰 일이 반드시 생깁니다. 비밀번호를 포스트잇에 써서 모니터에 붙이지 않듯이, 키와 계정도 다루는 규칙이 있습니다. 수업 공용 계정도, 여러분 ChatGPT 계정도 같은 규칙입니다.</a:t>
             </a:r>
           </a:p>
           <a:p/>
@@ -2137,21 +2137,21 @@
           <a:p>
             <a:r>
               <a:rPr lang="ko-KR"/>
-              <a:t>둘째, 특히 GitHub에 올리면 몇 분 안에 봇이 수집해 갑니다. 공개 저장소를 24시간 훑으면서 키처럼 생긴 문자열을 찾는 자동 프로그램들이 실제로 있습니다. 공용 키가 새면 남이 그 키로 요청을 보내고, 반 전체가 쓸 한도가 날아가고, 심하면 제 계정이 막힙니다. 실제로 매 학기 어디선가 한 명은 겪는 사고입니다.</a:t>
+              <a:t>둘째, 특히 GitHub에 올리면 몇 분 안에 봇이 수집해 갑니다. 공개 저장소를 24시간 훑으면서 키처럼 생긴 문자열을 찾는 자동 프로그램들이 실제로 있습니다. 키든 비밀번호든 새면 남이 내 이름으로 요청을 보내고, 한도와 요금과 계정이 한꺼번에 위험해집니다. 실제로 매 학기 어디선가 한 명은 겪는 사고입니다.</a:t>
             </a:r>
           </a:p>
           <a:p/>
           <a:p>
             <a:r>
               <a:rPr lang="ko-KR"/>
-              <a:t>셋째, 유출이 의심되면 숨기지 말고 즉시 알리세요. 공용 키는 제가 Z.ai에서 폐기하고 새로 만들면 됩니다. 키는 얼마든지 다시 만들 수 있으니, 실수했다고 숨기는 게 제일 나쁜 선택입니다. 내 ChatGPT 비밀번호가 샌 것 같으면 바로 바꾸고, 계정 설정에서 로그인된 기기를 확인하세요.</a:t>
+              <a:t>셋째, 유출이 의심되면 숨기지 말고 즉시 알리세요. 수업 공용 계정이 이상하게 돌아가면 저에게 바로 말하면 됩니다. 실수했다고 숨기는 게 제일 나쁜 선택입니다. 내 ChatGPT 비밀번호가 샌 것 같으면 바로 바꾸고, 계정 설정에서 로그인된 기기를 확인하세요.</a:t>
             </a:r>
           </a:p>
           <a:p/>
           <a:p>
             <a:r>
               <a:rPr lang="ko-KR"/>
-              <a:t>그래서 키는 코드 밖, 도구 설정 안에만 둡니다. 아래 상자입니다. ZCode의 Model settings 칸에만 붙여넣고, 코드에도, 메모장에도, 채팅방에도, 깃허브에도 적지 않습니다. 코드에는 키가 없으니 저장소에 올려도 안전합니다. 학기가 끝나면 공용 키는 폐기합니다. 그럼 이제 첫 지시로 갑니다.</a:t>
+              <a:t>그래서 비밀은 코드 밖, 도구 설정 안에만 둡니다. 아래 상자입니다. 오늘 ZCode는 제 계정 로그인으로, Codex는 여러분 ChatGPT 로그인으로 연결했습니다. 코드에도, 메모장에도, 채팅방에도, 깃허브에도 키나 비밀번호를 적지 않습니다. 공용 계정 비밀번호는 묻지도 적지도 않습니다. 그럼 이제 첫 지시로 갑니다.</a:t>
             </a:r>
           </a:p>
         </p:txBody>
@@ -2245,7 +2245,7 @@
           <a:p>
             <a:r>
               <a:rPr lang="ko-KR"/>
-              <a:t>왜 이렇게 시시할 만큼 작게 시키느냐, 왼쪽 카드입니다. 결과를 눈으로 전부 확인할 수 있는 크기이기 때문입니다. AI에게 처음부터 큰 걸 시키는 게 초보의 1번 실수입니다. "쇼핑몰 만들어 줘"라고 하면 파일 30개가 쏟아지는데, 그걸 확인할 수가 없어요. 확인 못 할 크기의 결과물은 받아도 쓸 수가 없습니다. "확인 가능한 크기로 시킨다"는 이번 학기 내내 지킬 원칙이고, 7주차에 본격적으로 다룹니다. 공용 키를 쓰는 수업 시간엔 한 가지 이유가 더 있죠. 큰 작업은 반 전체의 한도를 잡아먹습니다.</a:t>
+              <a:t>왜 이렇게 시시할 만큼 작게 시키느냐, 왼쪽 카드입니다. 결과를 눈으로 전부 확인할 수 있는 크기이기 때문입니다. AI에게 처음부터 큰 걸 시키는 게 초보의 1번 실수입니다. "쇼핑몰 만들어 줘"라고 하면 파일 30개가 쏟아지는데, 그걸 확인할 수가 없어요. 확인 못 할 크기의 결과물은 받아도 쓸 수가 없습니다. "확인 가능한 크기로 시킨다"는 이번 학기 내내 지킬 원칙이고, 7주차에 본격적으로 다룹니다. 공용 계정을 쓰는 수업 시간엔 한 가지 이유가 더 있죠. 큰 작업은 반 전체의 한도를 잡아먹습니다.</a:t>
             </a:r>
           </a:p>
           <a:p/>
@@ -2473,14 +2473,14 @@
           <a:p>
             <a:r>
               <a:rPr lang="ko-KR"/>
-              <a:t>둘째, 한도 초과와 기다리는 중. Codex는 무료 플랜 한도가 차면 잠시 막힙니다. 그럴 땐 ChatGPT 앱에서 GPT-5.6 Luna에게 묻고 코드를 붙여넣거나, 수업 시간이면 ZCode로 바꾸세요. ZCode에서 'Rate limit'이나 1302가 보이면 우리 반 여러 명이 동시에 눌러서 줄을 선 것입니다. 한도가 바닥난 게 아니라 순서 대기라서 몇 초 뒤 다시 보내면 됩니다. 5시간치 양을 다 쓴 경우는 드물지만, 큰 작업이 몰리면 날 수 있습니다. 그러면 그 시간대는 Codex로 넘어갑니다.</a:t>
+              <a:t>둘째, 한도 초과와 기다리는 중. Codex는 무료 플랜 한도가 차면 잠시 막힙니다. 그럴 땐 ChatGPT 앱에서 GPT-5.6 Luna에게 묻고 코드를 붙여넣거나, 수업 시간이면 ZCode로 바꾸세요. ZCode의 5시간치 양을 다 쓴 경우는 드물지만, 큰 작업이 몰리면 날 수 있습니다. 그러면 그 시간대는 Codex로 넘어갑니다. 둘 다 시간이 지나면 한도가 다시 찹니다.</a:t>
             </a:r>
           </a:p>
           <a:p/>
           <a:p>
             <a:r>
               <a:rPr lang="ko-KR"/>
-              <a:t>셋째, ZCode 연결 오류. 1113이라는 숫자나 키 오류가 보이면 설정을 다시 봅니다. 연결 방식이 API Key로 되어 있는지, 키 앞뒤에 공백이나 줄바꿈이 들어가지 않았는지, Base URL이 기본값 그대로인지. 1113은 보통 키가 아니라 주소가 잘못됐을 때 나는 오류입니다. 톱니바퀴, Model settings에서 확인하세요.</a:t>
+              <a:t>셋째, ZCode 연결이 끊긴 경우. ZCode 왼쪽 아래가 'Connected'인지 봅니다. 'Connect'로 바뀌어 있으면 계정 연결이 풀린 것이니 다시 로그인이 필요합니다. 혼자 하려고 하지 말고 질문하세요. 제가 다시 로그인해 드립니다. 그리고 'Rate limit'이나 1302가 보이면 우리 반 여러 명이 동시에 눌러서 줄을 선 것입니다. 한도가 바닥난 게 아니라 순서 대기라서 몇 초 뒤 다시 보내면 됩니다.</a:t>
             </a:r>
           </a:p>
           <a:p/>
@@ -2494,7 +2494,7 @@
           <a:p>
             <a:r>
               <a:rPr lang="ko-KR"/>
-              <a:t>맨 아래 상자는 비상구입니다. 한도가 다 찼을 때, 수업 중엔 ZCode, 집에선 ChatGPT 앱에서 GPT-5.6 Luna에게 물어보고 코드를 복사해 VS Code에 붙여넣으면 실습을 이어 갈 수 있습니다. ChatGPT 무료 계정은 글로 묻고 답하는 건 사실상 한도 없이 되고, 파일 올리기나 이미지 만들기 같은 기능에만 제한이 있습니다. 다만 이건 에이전트처럼 파일을 대신 만들어 주는 게 아니라 답을 읽고 내가 붙여넣는 방식이라, 1강에서 했던 '물어보기'와 같은 방식입니다. 둘 다 안 되면 다음 수업 전에 질문으로 남겨 주세요.</a:t>
+              <a:t>맨 아래 상자는 비상구입니다. 한도가 다 찼을 때, 수업 중엔 공용 계정의 ZCode, 집에선 ChatGPT 앱에서 GPT-5.6 Luna에게 물어보고 코드를 복사해 VS Code에 붙여넣으면 실습을 이어 갈 수 있습니다. ChatGPT 무료 계정은 글로 묻고 답하는 건 사실상 한도 없이 되고, 파일 올리기나 이미지 만들기 같은 기능에만 제한이 있습니다. 다만 이건 에이전트처럼 파일을 대신 만들어 주는 게 아니라 답을 읽고 내가 붙여넣는 방식이라, 1강에서 했던 '물어보기'와 같은 방식입니다. 둘 다 안 되면 다음 수업 전에 질문으로 남겨 주세요.</a:t>
             </a:r>
           </a:p>
         </p:txBody>
@@ -2581,7 +2581,7 @@
           <a:p>
             <a:r>
               <a:rPr lang="ko-KR"/>
-              <a:t>체크리스트 다섯 개입니다. 위에서부터. ChatGPT 무료 계정에 로그인했다. VS Code에 Codex 확장을 설치하고 ChatGPT로 로그인해 '안녕' 응답을 받았다. ZCode를 설치하고 수업 공용 키로 연결해 '안녕' 응답을 받았다. 지시로 temp.py가 생성되고 실행하면 77.0이 나온다. temp.py 안에 키가 없는 것을 확인하고 hello-sw 저장소에 push했다.</a:t>
+              <a:t>체크리스트 다섯 개입니다. 위에서부터. ChatGPT 무료 계정에 로그인했다. VS Code에 Codex 확장을 설치하고 ChatGPT로 로그인해 '안녕' 응답을 받았다. ZCode를 설치하고 수업 공용 계정으로 연결해 '안녕' 응답을 받았다. 지시로 temp.py가 생성되고 실행하면 77.0이 나온다. temp.py를 hello-sw 저장소에 push하고 저장소 주소를 제출했다.</a:t>
             </a:r>
           </a:p>
           <a:p/>
@@ -2595,7 +2595,7 @@
           <a:p>
             <a:r>
               <a:rPr lang="ko-KR"/>
-              <a:t>그리고 여기서 오늘 배운 게 바로 연결됩니다. temp.py를 GitHub에 올려도 되는 이유가 뭘까요? 코드 안에 키가 없기 때문입니다. 키는 ZCode 설정 안에만 넣었고 코드에는 한 글자도 없습니다. 그래서 코드는 공개해도 안전한 겁니다. 만약 코드에 키를 직접 박았다면 지금 push하는 순간 사고가 났을 거예요. 올리기 전에 VS Code에서 Ctrl+Shift+F로 전체 검색을 열고, 공용 키의 앞 여섯 글자를 검색해서 0건인지 한 번 보세요. 오늘 보안 슬라이드가 괜히 있었던 게 아닙니다.</a:t>
+              <a:t>그리고 여기서 오늘 배운 게 바로 연결됩니다. temp.py를 GitHub에 올려도 되는 이유가 뭘까요? 코드 안에 비밀이 없기 때문입니다. 로그인은 도구 설정 안에서 했고 코드에는 키도 비밀번호도 한 글자도 없습니다. 그래서 코드는 공개해도 안전한 겁니다. 만약 코드에 키를 직접 박았다면 지금 push하는 순간 사고가 났을 거예요. 오늘 보안 슬라이드가 괜히 있었던 게 아닙니다.</a:t>
             </a:r>
           </a:p>
           <a:p/>
@@ -2919,7 +2919,7 @@
           <a:p>
             <a:r>
               <a:rPr lang="ko-KR"/>
-              <a:t>아래 줄. 왼쪽은 Z.ai 공용 키입니다. Z.ai는 중국 Zhipu라는 회사의 생성형 AI 서비스이고, 제가 그 회사의 코딩 구독 상품, GLM Coding Plan을 구독해 두었습니다. 그 구독에 딸린 API 키를 수업 시간에 여러분에게 알려 드립니다. API 키가 뭐냐면, API는 프로그램끼리 대화하는 통로이고, 키는 그 통로를 쓸 때 "너 누구야"를 확인하는 열쇠입니다. 놀이공원 자유이용권 팔찌 같은 거예요. 오른쪽은 ZCode, Z.ai가 만든 코딩 에이전트 프로그램입니다. VS Code 확장이 아니라 따로 설치해서 따로 띄우는 프로그램인데, 같은 hello-sw 폴더를 열어 두면 ZCode가 고친 파일이 VS Code에도 그대로 보입니다. 두뇌는 GLM-5.3이라는 모델이고, 구독 한도가 넉넉해서 수업 시간 실습용으로 씁니다. 대신 반 전체가 한 키를 나눠 쓰니까 규칙이 있습니다. 지시는 작게, 그리고 키는 절대 밖으로 내보내지 않기. 이건 잠시 뒤 따로 한 장을 써서 얘기합니다.</a:t>
+              <a:t>아래 줄. 왼쪽은 Z.ai 공용 계정입니다. Z.ai는 중국 Zhipu라는 회사의 생성형 AI 서비스이고, 제가 그 회사의 코딩 구독 상품, GLM Coding Plan을 구독해 두었습니다. 그 계정을 수업 시간에 여러분 노트북에서 제가 직접 로그인해 드립니다. 놀이공원 자유이용권 팔찌를 같이 차는 셈이에요. 오른쪽은 ZCode, Z.ai가 만든 코딩 에이전트 프로그램입니다. VS Code 확장이 아니라 따로 설치해서 따로 띄우는 프로그램인데, 같은 hello-sw 폴더를 열어 두면 ZCode가 고친 파일이 VS Code에도 그대로 보입니다. 두뇌는 GLM-5.3이라는 모델이고, 구독 한도가 넉넉해서 수업 시간 실습용으로 씁니다. 대신 반 전체가 계정 하나를 나눠 쓰니까 규칙이 있습니다. 지시는 작게, 그리고 계정 정보는 묻지도 적지도 않기. 이건 잠시 뒤 따로 한 장을 써서 얘기합니다.</a:t>
             </a:r>
           </a:p>
           <a:p/>
@@ -3322,7 +3322,7 @@
           <a:p>
             <a:r>
               <a:rPr lang="ko-KR"/>
-              <a:t>3번. 처음 실행하면 오른쪽 그림 같은 환영 화면이 뜹니다. 버튼이 세 개입니다. 'Connect Z.ai to continue', 'Connect BigModel to continue', 그리고 'Use API key'. 위의 두 개는 계정으로 로그인하는 버튼인데, 그 계정은 교수님 것이라 여러분은 쓰지 않습니다. 맨 아래 'Use API key'를 누릅니다. 그러면 키를 넣는 설정 화면으로 넘어가는데, 그건 다음 장에서.</a:t>
+              <a:t>3번. 처음 실행하면 오른쪽 그림 같은 환영 화면이 뜹니다. 버튼이 세 개입니다. 'Connect Z.ai to continue', 'Connect BigModel to continue', 그리고 'Use API key'. 우리는 맨 위 'Connect Z.ai to continue'를 누릅니다. 그러면 브라우저가 열리면서 Z.ai 로그인 화면이 뜨는데, 거기서 제가 수업 공용 계정으로 로그인해 드립니다. 여러분이 직접 로그인할 계정이 아니니 그 화면이 뜨면 부르세요. 나머지 두 버튼, BigModel과 Use API key는 쓰지 않습니다. 연결이 끝나는 모습은 다음 장에서.</a:t>
             </a:r>
           </a:p>
           <a:p/>
@@ -3400,49 +3400,49 @@
           <a:p>
             <a:r>
               <a:rPr lang="ko-KR"/>
-              <a:t>다섯 번째 단계, ZCode에 수업 공용 키를 연결합니다. 왼쪽 그림은 ZCode 공식 문서에 있는 Model settings 화면인데, 우리가 지금 만들 상태 그대로입니다. Z.ai를 API Key 방식으로 연결한 모습이에요.</a:t>
+              <a:t>다섯 번째 단계, ZCode에 수업 공용 계정을 연결합니다. 왼쪽 그림은 ZCode 공식 문서에 있는 Model settings의 Z.ai 화면입니다. 연결이 안 된 상태라 'Not connected'와 'Connect to Z.ai' 버튼이 보이죠. 우리가 연결을 끝내면 이 자리가 'Connected'로 바뀝니다.</a:t>
             </a:r>
           </a:p>
           <a:p/>
           <a:p>
             <a:r>
               <a:rPr lang="ko-KR"/>
-              <a:t>1번. 앞 장에서 'Use API key'를 누르면 이 Model settings 화면이 열립니다. 왼쪽 목록에서 Z.ai를 선택합니다. 그림의 1번입니다. 그 아래 BigModel은 중국 내수용이라 우리 것이 아닙니다.</a:t>
+              <a:t>1번. 앞 장의 환영 화면에서 'Connect Z.ai to continue'를 누르면 브라우저가 열리고 Z.ai 로그인 화면이 뜹니다. 여기서 제가 와서 수업 공용 계정으로 로그인해 드립니다. 비밀번호는 알려 드리지 않습니다. 열 명이니까 한 명씩 돌면서 해 드릴 수 있어요.</a:t>
             </a:r>
           </a:p>
           <a:p/>
           <a:p>
             <a:r>
               <a:rPr lang="ko-KR"/>
-              <a:t>2번. 오른쪽 위에 연결 방식을 고르는 칸이 있습니다. 그림의 2번. 기본은 계정 로그인, Coding Plan이라고 되어 있는데, 이걸 API Key로 바꿉니다.</a:t>
+              <a:t>2번. 로그인이 되면 브라우저가 ZCode에게 이 계정을 써도 되겠냐고 묻습니다. 허용, Authorize를 누르면 브라우저가 ZCode로 돌아가고, ZCode가 계정을 자동으로 묶습니다. ZCode 왼쪽 아래에 'Connected'가 보이면 성공입니다.</a:t>
             </a:r>
           </a:p>
           <a:p/>
           <a:p>
             <a:r>
               <a:rPr lang="ko-KR"/>
-              <a:t>3번. Base URL 칸, 그림의 3번. 여기엔 https://api.z.ai/api/anthropic 이라는 주소가 이미 들어 있습니다. 건드리지 않습니다. 제가 이 주소로 우리 키가 동작하는 걸 확인했습니다.</a:t>
+              <a:t>3번. 모델은 GLM-5.3이 자동으로 잡힙니다. 제 계정에 딸린 GLM Coding Plan의 한도를 쓰는 거라서 따로 키를 넣을 일이 없습니다.</a:t>
             </a:r>
           </a:p>
           <a:p/>
           <a:p>
             <a:r>
               <a:rPr lang="ko-KR"/>
-              <a:t>4번. API Key 칸, 그림의 4번. 여기에 수업 공용 키를 붙여넣습니다. 키는 수업 시간에 따로 알려 드립니다. 앞뒤에 공백이나 줄바꿈이 섞이지 않게 복사하세요.</a:t>
+              <a:t>4번. 제대로 됐는지 확인하고 싶으면, 왼쪽 아래 톱니바퀴를 누르고 Model settings, 그 안에서 Z.ai를 고릅니다. 그림의 4번 자리예요. 오른쪽 위 Connection mode가 'Individual Plan'이고, Coding Plan 칸이 'Connected'로 되어 있으면 됩니다. 그림은 연결 전이라 'Not connected'입니다.</a:t>
             </a:r>
           </a:p>
           <a:p/>
           <a:p>
             <a:r>
               <a:rPr lang="ko-KR"/>
-              <a:t>5번. 제대로 들어가면 아래 Model list에 GLM-5.3과 GLM-5-Turbo가 보이고, 위에 'Enabled', 켜짐 표시가 나옵니다. GLM-5.3이 보이면 연결된 겁니다. 왼쪽 위 'Back to workspace'를 눌러 작업 화면으로 돌아갑니다.</a:t>
+              <a:t>5번. 나중에 연결이 끊겨서 'Not connected'로 돌아가 있으면, 그림의 5번 'Connect to Z.ai' 버튼으로 다시 로그인하면 됩니다. 그때도 제가 해 드립니다. 혼자 해결하려고 비밀번호를 추측하거나 찾지 마세요.</a:t>
             </a:r>
           </a:p>
           <a:p/>
           <a:p>
             <a:r>
               <a:rPr lang="ko-KR"/>
-              <a:t>아래 상자. 환영 화면의 'Connect Z.ai to continue' 버튼은 교수님 계정으로 들어가는 버튼이라 쓰지 않습니다. 키 한 줄만 넣으면 됩니다. 나중에 이 화면을 다시 열려면 왼쪽 아래 톱니바퀴를 누르고 Model settings. 그리고 이 키, 잠시 뒤에 따로 한 장 쓰겠지만 미리 한마디. 이건 제 계정의 비밀번호나 마찬가지입니다. 채팅방, 깃허브, 블로그 어디에도 올리지 않습니다.</a:t>
+              <a:t>아래 상자. 이 공용 계정은 수업용 노트북에서만 씁니다. 비밀번호를 묻지도, 적지도, 다른 기기에 로그인하지도 않습니다. 열 명이 계정 하나를 같이 쓰는 거라 한 명이 큰 작업을 돌리면 모두가 느려집니다. 지시는 작게. 잠시 뒤 비밀번호 장에서 한 번 더 얘기합니다.</a:t>
             </a:r>
           </a:p>
         </p:txBody>
@@ -3548,7 +3548,7 @@
           <a:p>
             <a:r>
               <a:rPr lang="ko-KR"/>
-              <a:t>5번. 'Rate limit'이라는 글자나 1302라는 숫자가 보이면, 반 전체가 같은 키를 쓰다 보니 동시에 요청이 몰려 줄을 선 겁니다. 오류가 아니라 순서 대기예요. 몇 초 뒤 다시 보내면 됩니다.</a:t>
+              <a:t>5번. 'Rate limit'이라는 글자나 1302라는 숫자가 보이면, 반 전체가 같은 계정을 쓰다 보니 동시에 요청이 몰려 줄을 선 겁니다. 오류가 아니라 순서 대기예요. 몇 초 뒤 다시 보내면 됩니다.</a:t>
             </a:r>
           </a:p>
           <a:p/>
@@ -3562,7 +3562,7 @@
           <a:p>
             <a:r>
               <a:rPr lang="ko-KR"/>
-              <a:t>여기까지 되면 두 에이전트가 다 붙은 겁니다. Codex는 VS Code 안에서, ZCode는 따로 뜬 창에서, 같은 hello-sw 폴더를 봅니다. 다음 장에서 키 얘기를 하고, 그다음 첫 지시로 갑니다.</a:t>
+              <a:t>여기까지 되면 두 에이전트가 다 붙은 겁니다. Codex는 VS Code 안에서, ZCode는 따로 뜬 창에서, 같은 hello-sw 폴더를 봅니다. 다음 장에서 비밀번호 얘기를 하고, 그다음 첫 지시로 갑니다.</a:t>
             </a:r>
           </a:p>
         </p:txBody>
@@ -3647,7 +3647,7 @@
           <a:p>
             <a:r>
               <a:rPr lang="ko-KR"/>
-              <a:t>오른쪽 카드, ZCode. 수업 공용 Z.ai 키로 씁니다. 수업 시간 실습용입니다. 모델 GLM-5.3이 똑똑하고 한도가 넉넉합니다. 다만 5시간 단위로 정해진 양을 반 전체가 나눠 씁니다. 스무 명이 나눠 써도 한 사람이 지시 백 번은 넘게 할 수 있는 양이지만, 동시에 몰리면 1302, 잠깐 대기가 뜹니다. 규칙 세 가지. 키 유출 금지, 큰 작업 금지, 학기가 끝나면 키 폐기. 큰 작업을 금지하는 이유는 한 사람이 '쇼핑몰 통째로 만들어 줘' 같은 걸 돌리면 공용 양을 혼자 잡아먹어서 모두가 느려지기 때문입니다.</a:t>
+              <a:t>오른쪽 카드, ZCode. 수업 공용 Z.ai 계정으로 씁니다. 수업 시간 실습용입니다. 모델 GLM-5.3이 똑똑하고 한도가 넉넉합니다. 다만 5시간 단위로 정해진 양을 반 전체가 나눠 씁니다. 열 명이 나눠 써도 한 사람이 지시 백 번은 넘게 할 수 있는 양이지만, 동시에 몰리면 1302, 잠깐 대기가 뜹니다. 규칙 네 가지. 계정 정보는 묻지도 적지도 않기, 다른 기기에 로그인하지 않기, 큰 작업 금지, 학기가 끝나면 로그아웃. 큰 작업을 금지하는 이유는 한 사람이 '쇼핑몰 통째로 만들어 줘' 같은 걸 돌리면 공용 양을 혼자 잡아먹어서 모두가 느려지기 때문입니다.</a:t>
             </a:r>
           </a:p>
           <a:p/>
@@ -4221,7 +4221,7 @@
                 <a:ea typeface="Malgun Gothic" pitchFamily="34" charset="-122"/>
                 <a:cs typeface="Malgun Gothic" pitchFamily="34" charset="-120"/>
               </a:rPr>
-              <a:t>그리고 AI 도구 환경 구축: ChatGPT 계정으로 Codex 로그인 · 수업 공용 키로 ZCode 연결 · 첫 지시</a:t>
+              <a:t>그리고 AI 도구 환경 구축: ChatGPT 계정으로 Codex 로그인 · 수업 공용 계정으로 ZCode 연결 · 첫 지시</a:t>
             </a:r>
             <a:endParaRPr lang="en-US" sz="1500" dirty="0"/>
           </a:p>
@@ -10232,7 +10232,7 @@
                 <a:ea typeface="Malgun Gothic" pitchFamily="34" charset="-122"/>
                 <a:cs typeface="Malgun Gothic" pitchFamily="34" charset="-120"/>
               </a:rPr>
-              <a:t>Z.ai 공용 키</a:t>
+              <a:t>Z.ai 공용 계정</a:t>
             </a:r>
           </a:p>
         </p:txBody>
@@ -10293,7 +10293,7 @@
                 <a:ea typeface="Malgun Gothic" pitchFamily="34" charset="-122"/>
                 <a:cs typeface="Malgun Gothic" pitchFamily="34" charset="-120"/>
               </a:rPr>
-              <a:t>수업 시간에 알려 드림</a:t>
+              <a:t>수업 시간에 로그인해 드림</a:t>
             </a:r>
           </a:p>
         </p:txBody>
@@ -10373,7 +10373,7 @@
                 <a:ea typeface="Malgun Gothic" pitchFamily="34" charset="-122"/>
                 <a:cs typeface="Malgun Gothic" pitchFamily="34" charset="-120"/>
               </a:rPr>
-              <a:t>키 입력</a:t>
+              <a:t>로그인</a:t>
             </a:r>
           </a:p>
         </p:txBody>
@@ -10737,7 +10737,7 @@
                 <a:ea typeface="Malgun Gothic" pitchFamily="34" charset="-122"/>
                 <a:cs typeface="Malgun Gothic" pitchFamily="34" charset="-120"/>
               </a:rPr>
-              <a:t>한도를 스무 명이 나눠 쓰니, 지시는 작게. 키는 절대 밖으로 내보내지 않기.</a:t>
+              <a:t>교수님 계정 하나를 열 명이 나눠 쓰니, 지시는 작게. 계정 정보는 묻지도 적지도 않기.</a:t>
             </a:r>
           </a:p>
         </p:txBody>
@@ -10906,7 +10906,7 @@
                 <a:ea typeface="Malgun Gothic" pitchFamily="34" charset="-122"/>
                 <a:cs typeface="Malgun Gothic" pitchFamily="34" charset="-120"/>
               </a:rPr>
-              <a:t>수업 시간엔 ZCode(공용 키), 집과 과제엔 Codex(내 계정). 한쪽이 막히면 다른 쪽으로 바꿔 씁니다. 오늘 실습은 이 네 조각을 위에서부터 하나씩 잇는 과정입니다. 지난주에 만든 작업대(VS Code, Git, GitHub)는 그대로 씁니다.</a:t>
+              <a:t>수업 시간엔 ZCode(공용 계정), 집과 과제엔 Codex(내 계정). 한쪽이 막히면 다른 쪽으로 바꿔 씁니다. 오늘 실습은 이 네 조각을 위에서부터 하나씩 잇는 과정입니다. 지난주에 만든 작업대(VS Code, Git, GitHub)는 그대로 씁니다.</a:t>
             </a:r>
           </a:p>
         </p:txBody>
@@ -16108,7 +16108,7 @@
                 <a:ea typeface="Malgun Gothic" pitchFamily="34" charset="-122"/>
                 <a:cs typeface="Malgun Gothic" pitchFamily="34" charset="-120"/>
               </a:rPr>
-              <a:t>첫 화면에서 'Use API key' 선택</a:t>
+              <a:t>첫 화면에서 'Connect Z.ai to continue'</a:t>
             </a:r>
           </a:p>
         </p:txBody>
@@ -16150,7 +16150,7 @@
                 <a:ea typeface="Malgun Gothic" pitchFamily="34" charset="-122"/>
                 <a:cs typeface="Malgun Gothic" pitchFamily="34" charset="-120"/>
               </a:rPr>
-              <a:t>위의 'Connect Z.ai' 와 'Connect BigModel' 은 계정 로그인 버튼입니다. 교수님 계정이라 쓰지 않습니다. 맨 아래 'Use API key'.</a:t>
+              <a:t>맨 위 버튼입니다. 브라우저가 열리면 교수님이 수업 공용 계정으로 로그인해 드립니다. 'Connect BigModel'과 'Use API key'는 쓰지 않습니다.</a:t>
             </a:r>
           </a:p>
         </p:txBody>
@@ -16552,14 +16552,14 @@
                 <a:ea typeface="Malgun Gothic" pitchFamily="34" charset="-122"/>
                 <a:cs typeface="Malgun Gothic" pitchFamily="34" charset="-120"/>
               </a:rPr>
-              <a:t>⑤ ZCode에 수업 공용 키 연결</a:t>
+              <a:t>⑤ ZCode에 수업 공용 계정 연결</a:t>
             </a:r>
           </a:p>
         </p:txBody>
       </p:sp>
       <p:pic>
         <p:nvPicPr>
-          <p:cNvPr id="6" name="Picture 5" descr="zcode_zai_apikey.png"/>
+          <p:cNvPr id="6" name="Picture 5" descr="zcode_zai_plan.png"/>
           <p:cNvPicPr>
             <a:picLocks noChangeAspect="1"/>
           </p:cNvPicPr>
@@ -16574,7 +16574,7 @@
         <p:spPr>
           <a:xfrm>
             <a:off x="658368" y="1691640"/>
-            <a:ext cx="5486400" cy="3448594"/>
+            <a:ext cx="5486400" cy="2677885"/>
           </a:xfrm>
           <a:prstGeom prst="rect">
             <a:avLst/>
@@ -16589,8 +16589,8 @@
         </p:nvSpPr>
         <p:spPr>
           <a:xfrm>
-            <a:off x="658368" y="5185954"/>
-            <a:ext cx="5486400" cy="411480"/>
+            <a:off x="658368" y="4415245"/>
+            <a:ext cx="5486400" cy="548640"/>
           </a:xfrm>
           <a:prstGeom prst="rect">
             <a:avLst/>
@@ -16618,7 +16618,7 @@
                 <a:ea typeface="Malgun Gothic" pitchFamily="34" charset="-122"/>
                 <a:cs typeface="Malgun Gothic" pitchFamily="34" charset="-120"/>
               </a:rPr>
-              <a:t>ZCode 설정 → Model settings 화면 (출처: ZCode 공식 문서). Z.ai를 'API Key' 방식으로 연결한 모습.</a:t>
+              <a:t>ZCode 설정 → Model settings의 Z.ai 화면 (출처: ZCode 공식 문서). 'Individual Plan' 모드에서 'Connect to Z.ai'를 누르면 계정 로그인으로 넘어갑니다. 첫 화면에서 이미 연결했다면 여기서 확인만 합니다.</a:t>
             </a:r>
           </a:p>
         </p:txBody>
@@ -16737,7 +16737,7 @@
                 <a:ea typeface="Malgun Gothic" pitchFamily="34" charset="-122"/>
                 <a:cs typeface="Malgun Gothic" pitchFamily="34" charset="-120"/>
               </a:rPr>
-              <a:t>왼쪽 목록에서 Z.ai 선택</a:t>
+              <a:t>'Connect Z.ai to continue' → 브라우저가 열림</a:t>
             </a:r>
           </a:p>
         </p:txBody>
@@ -16751,7 +16751,7 @@
         <p:spPr>
           <a:xfrm>
             <a:off x="6967728" y="1965960"/>
-            <a:ext cx="4562856" cy="411480"/>
+            <a:ext cx="4562856" cy="457200"/>
           </a:xfrm>
           <a:prstGeom prst="rect">
             <a:avLst/>
@@ -16779,7 +16779,7 @@
                 <a:ea typeface="Malgun Gothic" pitchFamily="34" charset="-122"/>
                 <a:cs typeface="Malgun Gothic" pitchFamily="34" charset="-120"/>
               </a:rPr>
-              <a:t>'Use API key'를 누르면 이 Model settings 화면이 열립니다.</a:t>
+              <a:t>교수님이 와서 수업 공용 계정으로 로그인해 드립니다. 비밀번호는 알려 드리지 않습니다.</a:t>
             </a:r>
           </a:p>
         </p:txBody>
@@ -16792,7 +16792,7 @@
         </p:nvSpPr>
         <p:spPr>
           <a:xfrm>
-            <a:off x="6400800" y="2441448"/>
+            <a:off x="6400800" y="2487168"/>
             <a:ext cx="384048" cy="384048"/>
           </a:xfrm>
           <a:prstGeom prst="ellipse">
@@ -16833,7 +16833,7 @@
         </p:nvSpPr>
         <p:spPr>
           <a:xfrm>
-            <a:off x="6400800" y="2441448"/>
+            <a:off x="6400800" y="2487168"/>
             <a:ext cx="384048" cy="384048"/>
           </a:xfrm>
           <a:prstGeom prst="rect">
@@ -16872,7 +16872,7 @@
         </p:nvSpPr>
         <p:spPr>
           <a:xfrm>
-            <a:off x="6967728" y="2423160"/>
+            <a:off x="6967728" y="2468880"/>
             <a:ext cx="4562856" cy="274320"/>
           </a:xfrm>
           <a:prstGeom prst="rect">
@@ -16898,7 +16898,7 @@
                 <a:ea typeface="Malgun Gothic" pitchFamily="34" charset="-122"/>
                 <a:cs typeface="Malgun Gothic" pitchFamily="34" charset="-120"/>
               </a:rPr>
-              <a:t>오른쪽 위 연결 방식 → API Key</a:t>
+              <a:t>브라우저에서 '허용(Authorize)' → ZCode로 돌아옴</a:t>
             </a:r>
           </a:p>
         </p:txBody>
@@ -16911,8 +16911,8 @@
         </p:nvSpPr>
         <p:spPr>
           <a:xfrm>
-            <a:off x="6967728" y="2697479"/>
-            <a:ext cx="4562856" cy="411480"/>
+            <a:off x="6967728" y="2743200"/>
+            <a:ext cx="4562856" cy="457200"/>
           </a:xfrm>
           <a:prstGeom prst="rect">
             <a:avLst/>
@@ -16940,7 +16940,7 @@
                 <a:ea typeface="Malgun Gothic" pitchFamily="34" charset="-122"/>
                 <a:cs typeface="Malgun Gothic" pitchFamily="34" charset="-120"/>
               </a:rPr>
-              <a:t>기본은 계정 로그인(Coding Plan)이니 API Key로 바꿉니다.</a:t>
+              <a:t>인증이 끝나면 ZCode가 계정을 자동으로 묶습니다. 왼쪽 아래에 'Connected'가 보이면 성공.</a:t>
             </a:r>
           </a:p>
         </p:txBody>
@@ -16953,7 +16953,7 @@
         </p:nvSpPr>
         <p:spPr>
           <a:xfrm>
-            <a:off x="6400800" y="3172968"/>
+            <a:off x="6400800" y="3264408"/>
             <a:ext cx="384048" cy="384048"/>
           </a:xfrm>
           <a:prstGeom prst="ellipse">
@@ -16994,7 +16994,7 @@
         </p:nvSpPr>
         <p:spPr>
           <a:xfrm>
-            <a:off x="6400800" y="3172968"/>
+            <a:off x="6400800" y="3264408"/>
             <a:ext cx="384048" cy="384048"/>
           </a:xfrm>
           <a:prstGeom prst="rect">
@@ -17033,7 +17033,7 @@
         </p:nvSpPr>
         <p:spPr>
           <a:xfrm>
-            <a:off x="6967728" y="3154680"/>
+            <a:off x="6967728" y="3246120"/>
             <a:ext cx="4562856" cy="274320"/>
           </a:xfrm>
           <a:prstGeom prst="rect">
@@ -17059,7 +17059,7 @@
                 <a:ea typeface="Malgun Gothic" pitchFamily="34" charset="-122"/>
                 <a:cs typeface="Malgun Gothic" pitchFamily="34" charset="-120"/>
               </a:rPr>
-              <a:t>Base URL은 기본값 그대로</a:t>
+              <a:t>모델은 GLM-5.3이 자동으로 잡힘</a:t>
             </a:r>
           </a:p>
         </p:txBody>
@@ -17072,7 +17072,7 @@
         </p:nvSpPr>
         <p:spPr>
           <a:xfrm>
-            <a:off x="6967728" y="3429000"/>
+            <a:off x="6967728" y="3520439"/>
             <a:ext cx="4562856" cy="411480"/>
           </a:xfrm>
           <a:prstGeom prst="rect">
@@ -17101,7 +17101,7 @@
                 <a:ea typeface="Malgun Gothic" pitchFamily="34" charset="-122"/>
                 <a:cs typeface="Malgun Gothic" pitchFamily="34" charset="-120"/>
               </a:rPr>
-              <a:t>https://api.z.ai/api/anthropic 이 이미 들어 있습니다. 건드리지 않습니다.</a:t>
+              <a:t>교수님 계정의 GLM Coding Plan 한도를 씁니다. 따로 키를 넣지 않습니다.</a:t>
             </a:r>
           </a:p>
         </p:txBody>
@@ -17114,7 +17114,7 @@
         </p:nvSpPr>
         <p:spPr>
           <a:xfrm>
-            <a:off x="6400800" y="3904487"/>
+            <a:off x="6400800" y="3995927"/>
             <a:ext cx="384048" cy="384048"/>
           </a:xfrm>
           <a:prstGeom prst="ellipse">
@@ -17155,7 +17155,7 @@
         </p:nvSpPr>
         <p:spPr>
           <a:xfrm>
-            <a:off x="6400800" y="3904487"/>
+            <a:off x="6400800" y="3995927"/>
             <a:ext cx="384048" cy="384048"/>
           </a:xfrm>
           <a:prstGeom prst="rect">
@@ -17194,7 +17194,7 @@
         </p:nvSpPr>
         <p:spPr>
           <a:xfrm>
-            <a:off x="6967728" y="3886200"/>
+            <a:off x="6967728" y="3977639"/>
             <a:ext cx="4562856" cy="274320"/>
           </a:xfrm>
           <a:prstGeom prst="rect">
@@ -17220,7 +17220,7 @@
                 <a:ea typeface="Malgun Gothic" pitchFamily="34" charset="-122"/>
                 <a:cs typeface="Malgun Gothic" pitchFamily="34" charset="-120"/>
               </a:rPr>
-              <a:t>API Key 칸에 수업 공용 키 붙여넣기</a:t>
+              <a:t>확인: 왼쪽 아래 톱니바퀴 → Model settings → Z.ai</a:t>
             </a:r>
           </a:p>
         </p:txBody>
@@ -17233,8 +17233,8 @@
         </p:nvSpPr>
         <p:spPr>
           <a:xfrm>
-            <a:off x="6967728" y="4160520"/>
-            <a:ext cx="4562856" cy="411480"/>
+            <a:off x="6967728" y="4251959"/>
+            <a:ext cx="4562856" cy="457200"/>
           </a:xfrm>
           <a:prstGeom prst="rect">
             <a:avLst/>
@@ -17262,7 +17262,7 @@
                 <a:ea typeface="Malgun Gothic" pitchFamily="34" charset="-122"/>
                 <a:cs typeface="Malgun Gothic" pitchFamily="34" charset="-120"/>
               </a:rPr>
-              <a:t>키는 수업 시간에 따로 알려 드립니다. 앞뒤 공백·줄바꿈이 섞이지 않게.</a:t>
+              <a:t>Connection mode가 'Individual Plan', Coding Plan이 'Connected'로 보이면 됩니다.</a:t>
             </a:r>
           </a:p>
         </p:txBody>
@@ -17275,7 +17275,7 @@
         </p:nvSpPr>
         <p:spPr>
           <a:xfrm>
-            <a:off x="6400800" y="4636007"/>
+            <a:off x="6400800" y="4773168"/>
             <a:ext cx="384048" cy="384048"/>
           </a:xfrm>
           <a:prstGeom prst="ellipse">
@@ -17316,7 +17316,7 @@
         </p:nvSpPr>
         <p:spPr>
           <a:xfrm>
-            <a:off x="6400800" y="4636007"/>
+            <a:off x="6400800" y="4773168"/>
             <a:ext cx="384048" cy="384048"/>
           </a:xfrm>
           <a:prstGeom prst="rect">
@@ -17355,7 +17355,7 @@
         </p:nvSpPr>
         <p:spPr>
           <a:xfrm>
-            <a:off x="6967728" y="4617720"/>
+            <a:off x="6967728" y="4754880"/>
             <a:ext cx="4562856" cy="274320"/>
           </a:xfrm>
           <a:prstGeom prst="rect">
@@ -17381,7 +17381,7 @@
                 <a:ea typeface="Malgun Gothic" pitchFamily="34" charset="-122"/>
                 <a:cs typeface="Malgun Gothic" pitchFamily="34" charset="-120"/>
               </a:rPr>
-              <a:t>GLM-5.3이 보이면 성공 → Back to workspace</a:t>
+              <a:t>끊겼으면 'Connect to Z.ai'로 다시</a:t>
             </a:r>
           </a:p>
         </p:txBody>
@@ -17394,8 +17394,8 @@
         </p:nvSpPr>
         <p:spPr>
           <a:xfrm>
-            <a:off x="6967728" y="4892040"/>
-            <a:ext cx="4562856" cy="502920"/>
+            <a:off x="6967728" y="5029200"/>
+            <a:ext cx="4562856" cy="457200"/>
           </a:xfrm>
           <a:prstGeom prst="rect">
             <a:avLst/>
@@ -17423,7 +17423,7 @@
                 <a:ea typeface="Malgun Gothic" pitchFamily="34" charset="-122"/>
                 <a:cs typeface="Malgun Gothic" pitchFamily="34" charset="-120"/>
               </a:rPr>
-              <a:t>GLM-5.3이 보이면 연결된 겁니다. 왼쪽 위 'Back to workspace'로 돌아갑니다.</a:t>
+              <a:t>'Not connected'면 이 버튼으로 다시 로그인합니다. 그때도 교수님이 해 드립니다.</a:t>
             </a:r>
           </a:p>
         </p:txBody>
@@ -17573,7 +17573,7 @@
                 <a:ea typeface="Malgun Gothic" pitchFamily="34" charset="-122"/>
                 <a:cs typeface="Malgun Gothic" pitchFamily="34" charset="-120"/>
               </a:rPr>
-              <a:t>'Connect Z.ai to continue'(계정 로그인)는 교수님 계정으로 들어가는 버튼이라 쓰지 않습니다. 키 한 줄만 넣습니다. 나중에 다시 열려면 왼쪽 아래 톱니바퀴 → Model settings. 키는 두 번째 장에서 다시 얘기합니다.</a:t>
+              <a:t>공용 계정은 수업용 노트북에서만 씁니다. 비밀번호를 묻지도, 적지도, 다른 기기에 로그인하지도 않습니다. 열 명이 계정 하나를 같이 쓰는 거라 한 명이 큰 작업을 돌리면 모두가 느려집니다. 지시는 작게.</a:t>
             </a:r>
           </a:p>
         </p:txBody>
@@ -18825,7 +18825,7 @@
                 <a:ea typeface="Malgun Gothic" pitchFamily="34" charset="-122"/>
                 <a:cs typeface="Malgun Gothic" pitchFamily="34" charset="-120"/>
               </a:rPr>
-              <a:t>반 전체가 같은 키를 써서 줄을 선 겁니다. 몇 초 뒤 다시 보내면 됩니다.</a:t>
+              <a:t>반 전체가 같은 계정을 써서 줄을 선 겁니다. 몇 초 뒤 다시 보내면 됩니다.</a:t>
             </a:r>
           </a:p>
         </p:txBody>
@@ -18975,7 +18975,7 @@
                 <a:ea typeface="Malgun Gothic" pitchFamily="34" charset="-122"/>
                 <a:cs typeface="Malgun Gothic" pitchFamily="34" charset="-120"/>
               </a:rPr>
-              <a:t>여기까지 되면 두 에이전트가 다 붙은 겁니다. Codex는 VS Code 안에서, ZCode는 따로 뜬 창에서, 같은 hello-sw 폴더를 봅니다. 다음 장, 키 얘기를 하고 첫 지시로 갑니다.</a:t>
+              <a:t>여기까지 되면 두 에이전트가 다 붙은 겁니다. Codex는 VS Code 안에서, ZCode는 따로 뜬 창에서, 같은 hello-sw 폴더를 봅니다. 다음 장, 비밀번호 얘기를 하고 첫 지시로 갑니다.</a:t>
             </a:r>
           </a:p>
         </p:txBody>
@@ -19173,7 +19173,7 @@
                 <a:ea typeface="Malgun Gothic" pitchFamily="34" charset="-122"/>
                 <a:cs typeface="Malgun Gothic" pitchFamily="34" charset="-120"/>
               </a:rPr>
-              <a:t>API 키는 비밀번호입니다</a:t>
+              <a:t>키와 계정은 비밀번호입니다</a:t>
             </a:r>
             <a:endParaRPr lang="en-US" sz="2600" dirty="0"/>
           </a:p>
@@ -19302,7 +19302,7 @@
                 <a:ea typeface="Malgun Gothic" pitchFamily="34" charset="-122"/>
                 <a:cs typeface="Malgun Gothic" pitchFamily="34" charset="-120"/>
               </a:rPr>
-              <a:t>api_key = "..." 처럼 소스 코드에 키를 박는 순간, 그 파일이 가는 모든 곳에 비밀번호가 따라갑니다. 공용 키도 계정 비밀번호도 같습니다.</a:t>
+              <a:t>api_key = "..." 처럼 소스 코드에 키를 박는 순간, 그 파일이 가는 모든 곳에 비밀번호가 따라갑니다. 앞으로 직접 키를 다룰 때 첫 번째 규칙입니다.</a:t>
             </a:r>
             <a:endParaRPr lang="en-US" sz="1150" dirty="0"/>
           </a:p>
@@ -19431,7 +19431,7 @@
                 <a:ea typeface="Malgun Gothic" pitchFamily="34" charset="-122"/>
                 <a:cs typeface="Malgun Gothic" pitchFamily="34" charset="-120"/>
               </a:rPr>
-              <a:t>공개 저장소를 훑는 봇이 상시 돌고 있습니다. 공용 키가 새면 남이 그 키로 요청을 보내고, 반 전체 한도가 날아가고 교수님 계정이 막힐 수 있습니다.</a:t>
+              <a:t>공개 저장소를 훑는 봇이 상시 돌고 있습니다. 키든 비밀번호든 새면 남이 내 이름으로 요청을 보내고, 한도와 요금과 계정이 한꺼번에 위험해집니다.</a:t>
             </a:r>
             <a:endParaRPr lang="en-US" sz="1150" dirty="0"/>
           </a:p>
@@ -19518,7 +19518,7 @@
                 <a:ea typeface="Malgun Gothic" pitchFamily="34" charset="-122"/>
                 <a:cs typeface="Malgun Gothic" pitchFamily="34" charset="-120"/>
               </a:rPr>
-              <a:t>유출이 의심되면 즉시 알리기 · 폐기 · 재발급</a:t>
+              <a:t>유출이 의심되면 즉시 알리기 · 비밀번호 바꾸기</a:t>
             </a:r>
             <a:endParaRPr lang="en-US" sz="1400" dirty="0"/>
           </a:p>
@@ -19560,7 +19560,7 @@
                 <a:ea typeface="Malgun Gothic" pitchFamily="34" charset="-122"/>
                 <a:cs typeface="Malgun Gothic" pitchFamily="34" charset="-120"/>
               </a:rPr>
-              <a:t>공용 키는 교수님이 Z.ai에서 폐기하고 새로 만듭니다. 내 ChatGPT 비밀번호는 바로 바꾸고 로그인 기기를 확인합니다. 키는 얼마든지 다시 만들 수 있으니 숨기지 말고 알리세요.</a:t>
+              <a:t>수업 공용 계정이 이상하면 교수님에게 바로 알리세요. 내 ChatGPT 비밀번호가 샌 것 같으면 바로 바꾸고 로그인된 기기를 확인합니다. 실수를 숨기는 게 제일 나쁜 선택입니다.</a:t>
             </a:r>
             <a:endParaRPr lang="en-US" sz="1150" dirty="0"/>
           </a:p>
@@ -19676,7 +19676,7 @@
                 <a:ea typeface="Malgun Gothic" pitchFamily="34" charset="-122"/>
                 <a:cs typeface="Malgun Gothic" pitchFamily="34" charset="-120"/>
               </a:rPr>
-              <a:t>그래서 키는 '도구 설정 안'에만 넣습니다
+              <a:t>그래서 비밀은 '도구 설정 안'에만 둡니다
 </a:t>
             </a:r>
             <a:pPr indent="0" marL="0">
@@ -19694,7 +19694,7 @@
                 <a:ea typeface="Malgun Gothic" pitchFamily="34" charset="-122"/>
                 <a:cs typeface="Malgun Gothic" pitchFamily="34" charset="-120"/>
               </a:rPr>
-              <a:t>ZCode의 Model settings 칸에만 붙여넣고, 코드·메모·채팅·깃허브 어디에도 적지 않습니다. 코드에는 키가 없으니 저장소에 올려도 안전합니다. 학기가 끝나면 공용 키는 폐기됩니다.</a:t>
+              <a:t>ZCode는 교수님 계정 로그인으로, Codex는 내 ChatGPT 로그인으로 연결했습니다. 코드·메모·채팅·깃허브에는 키도 비밀번호도 적지 않습니다. 공용 계정 비밀번호는 묻지도 적지도 않습니다.</a:t>
             </a:r>
             <a:endParaRPr lang="en-US" sz="1300" dirty="0"/>
           </a:p>
@@ -23281,7 +23281,7 @@
                 <a:ea typeface="Malgun Gothic" pitchFamily="34" charset="-122"/>
                 <a:cs typeface="Malgun Gothic" pitchFamily="34" charset="-120"/>
               </a:rPr>
-              <a:t>ZCode  (수업 공용 Z.ai 키)</a:t>
+              <a:t>ZCode  (수업 공용 Z.ai 계정)</a:t>
             </a:r>
           </a:p>
         </p:txBody>
@@ -23529,7 +23529,7 @@
                 <a:ea typeface="Malgun Gothic" pitchFamily="34" charset="-122"/>
                 <a:cs typeface="Malgun Gothic" pitchFamily="34" charset="-120"/>
               </a:rPr>
-              <a:t>5시간 단위 양을 반 전체가 나눠 씁니다(1인당 지시 100번 넘게 가능). 동시에 몰리면 1302, 잠깐 대기.</a:t>
+              <a:t>5시간 단위 양을 반 전체가 나눠 씁니다(열 명이면 1인당 지시 100번 넘게 가능). 동시에 몰리면 1302, 잠깐 대기.</a:t>
             </a:r>
           </a:p>
         </p:txBody>
@@ -23653,7 +23653,7 @@
                 <a:ea typeface="Malgun Gothic" pitchFamily="34" charset="-122"/>
                 <a:cs typeface="Malgun Gothic" pitchFamily="34" charset="-120"/>
               </a:rPr>
-              <a:t>키 유출 금지, 큰 작업 금지(모두가 느려짐), 학기가 끝나면 키 폐기.</a:t>
+              <a:t>계정 정보 묻지·적지 않기, 다른 기기 로그인 금지, 큰 작업 금지(모두가 느려짐), 학기 끝나면 로그아웃.</a:t>
             </a:r>
           </a:p>
         </p:txBody>
@@ -24344,7 +24344,7 @@
                 <a:ea typeface="Malgun Gothic" pitchFamily="34" charset="-122"/>
                 <a:cs typeface="Malgun Gothic" pitchFamily="34" charset="-120"/>
               </a:rPr>
-              <a:t>Codex 무료 한도가 차면 ChatGPT 앱의 Luna에게 묻거나 ZCode로. ZCode에서 1302는 반 전체가 동시에 눌러 줄을 선 것, 몇 초 뒤 다시 보내면 됩니다.</a:t>
+              <a:t>Codex 무료 한도가 차면 ChatGPT 앱의 Luna에게 묻거나 ZCode로. ZCode의 5시간 한도가 다 찼으면 그 시간대는 Codex로. 둘 다 시간이 지나면 한도가 다시 찹니다.</a:t>
             </a:r>
             <a:endParaRPr lang="en-US" sz="1100" dirty="0"/>
           </a:p>
@@ -24464,7 +24464,7 @@
                 <a:ea typeface="Malgun Gothic" pitchFamily="34" charset="-122"/>
                 <a:cs typeface="Malgun Gothic" pitchFamily="34" charset="-120"/>
               </a:rPr>
-              <a:t>ZCode 연결 오류 (1113 · 키 오류)</a:t>
+              <a:t>ZCode 연결이 끊겼어요 · 1302</a:t>
             </a:r>
             <a:endParaRPr lang="en-US" sz="1350" dirty="0"/>
           </a:p>
@@ -24506,7 +24506,7 @@
                 <a:ea typeface="Malgun Gothic" pitchFamily="34" charset="-122"/>
                 <a:cs typeface="Malgun Gothic" pitchFamily="34" charset="-120"/>
               </a:rPr>
-              <a:t>연결 방식이 API Key인지, 키 앞뒤에 공백·줄바꿈이 없는지, Base URL이 기본값 그대로인지 확인. 1113은 키가 아니라 주소가 잘못된 경우입니다.</a:t>
+              <a:t>왼쪽 아래가 'Connected'인지 확인. 'Connect'로 바뀌어 있으면 다시 로그인이 필요하니 질문하세요. 1302·'Rate limit'은 반 전체가 동시에 눌러 줄을 선 것, 몇 초 뒤 다시.</a:t>
             </a:r>
             <a:endParaRPr lang="en-US" sz="1100" dirty="0"/>
           </a:p>
@@ -24858,7 +24858,7 @@
                 <a:ea typeface="Malgun Gothic" pitchFamily="34" charset="-122"/>
                 <a:cs typeface="Malgun Gothic" pitchFamily="34" charset="-120"/>
               </a:rPr>
-              <a:t>한도가 다 찼을 때: 수업 중엔 ZCode(공용 키), 집에선 ChatGPT 앱에서 GPT-5.6 Luna에게 물어보고 코드를 붙여넣으세요. 둘 다 안 되면 다음 수업 전에 질문으로 남겨 주세요.</a:t>
+              <a:t>한도가 다 찼을 때: 수업 중엔 ZCode(공용 계정), 집에선 ChatGPT 앱에서 GPT-5.6 Luna에게 물어보고 코드를 붙여넣으세요. 둘 다 안 되면 다음 수업 전에 질문으로 남겨 주세요.</a:t>
             </a:r>
           </a:p>
         </p:txBody>
@@ -25320,7 +25320,7 @@
                 <a:ea typeface="Malgun Gothic" pitchFamily="34" charset="-122"/>
                 <a:cs typeface="Malgun Gothic" pitchFamily="34" charset="-120"/>
               </a:rPr>
-              <a:t>ZCode를 설치하고 수업 공용 키로 연결해 '안녕' 응답을 받았다.</a:t>
+              <a:t>ZCode를 설치하고 수업 공용 계정으로 연결해 '안녕' 응답을 받았다.</a:t>
             </a:r>
             <a:endParaRPr lang="en-US" sz="1350" dirty="0"/>
           </a:p>
@@ -25500,7 +25500,7 @@
                 <a:ea typeface="Malgun Gothic" pitchFamily="34" charset="-122"/>
                 <a:cs typeface="Malgun Gothic" pitchFamily="34" charset="-120"/>
               </a:rPr>
-              <a:t>temp.py 안에 키가 없는 것을 확인하고 hello-sw 저장소에 push했다.</a:t>
+              <a:t>temp.py 를 hello-sw 저장소에 push하고 저장소 주소를 제출했다.</a:t>
             </a:r>
             <a:endParaRPr lang="en-US" sz="1350" dirty="0"/>
           </a:p>

</xml_diff>